<commit_message>
Work on the Admin guide
</commit_message>
<xml_diff>
--- a/assets/images/Administration.pptx
+++ b/assets/images/Administration.pptx
@@ -5,11 +5,10 @@
     <p:sldMasterId id="2147483684" r:id="rId4"/>
   </p:sldMasterIdLst>
   <p:notesMasterIdLst>
-    <p:notesMasterId r:id="rId7"/>
+    <p:notesMasterId r:id="rId6"/>
   </p:notesMasterIdLst>
   <p:sldIdLst>
     <p:sldId id="256" r:id="rId5"/>
-    <p:sldId id="257" r:id="rId6"/>
   </p:sldIdLst>
   <p:sldSz cx="21601113" cy="14400213"/>
   <p:notesSz cx="9144000" cy="6858000"/>
@@ -403,7 +402,7 @@
           <a:p>
             <a:fld id="{43466010-90F5-41E6-AAE8-7E580DBF8C7C}" type="datetimeFigureOut">
               <a:rPr lang="en-DK" smtClean="0"/>
-              <a:t>23/02/2026</a:t>
+              <a:t>24/02/2026</a:t>
             </a:fld>
             <a:endParaRPr lang="en-DK"/>
           </a:p>
@@ -759,94 +758,6 @@
 </p:notes>
 </file>
 
-<file path=ppt/notesSlides/notesSlide2.xml><?xml version="1.0" encoding="utf-8"?>
-<p:notes xmlns:a="http://schemas.openxmlformats.org/drawingml/2006/main" xmlns:r="http://schemas.openxmlformats.org/officeDocument/2006/relationships" xmlns:p="http://schemas.openxmlformats.org/presentationml/2006/main">
-  <p:cSld>
-    <p:spTree>
-      <p:nvGrpSpPr>
-        <p:cNvPr id="1" name=""/>
-        <p:cNvGrpSpPr/>
-        <p:nvPr/>
-      </p:nvGrpSpPr>
-      <p:grpSpPr>
-        <a:xfrm>
-          <a:off x="0" y="0"/>
-          <a:ext cx="0" cy="0"/>
-          <a:chOff x="0" y="0"/>
-          <a:chExt cx="0" cy="0"/>
-        </a:xfrm>
-      </p:grpSpPr>
-      <p:sp>
-        <p:nvSpPr>
-          <p:cNvPr id="2" name="Slide Image Placeholder 1"/>
-          <p:cNvSpPr>
-            <a:spLocks noGrp="1" noRot="1" noChangeAspect="1"/>
-          </p:cNvSpPr>
-          <p:nvPr>
-            <p:ph type="sldImg"/>
-          </p:nvPr>
-        </p:nvSpPr>
-        <p:spPr/>
-      </p:sp>
-      <p:sp>
-        <p:nvSpPr>
-          <p:cNvPr id="3" name="Notes Placeholder 2"/>
-          <p:cNvSpPr>
-            <a:spLocks noGrp="1"/>
-          </p:cNvSpPr>
-          <p:nvPr>
-            <p:ph type="body" idx="1"/>
-          </p:nvPr>
-        </p:nvSpPr>
-        <p:spPr/>
-        <p:txBody>
-          <a:bodyPr/>
-          <a:lstStyle/>
-          <a:p>
-            <a:r>
-              <a:rPr lang="en-GB" dirty="0"/>
-              <a:t>LabBench I/O</a:t>
-            </a:r>
-            <a:endParaRPr lang="en-DK" dirty="0"/>
-          </a:p>
-        </p:txBody>
-      </p:sp>
-      <p:sp>
-        <p:nvSpPr>
-          <p:cNvPr id="4" name="Slide Number Placeholder 3"/>
-          <p:cNvSpPr>
-            <a:spLocks noGrp="1"/>
-          </p:cNvSpPr>
-          <p:nvPr>
-            <p:ph type="sldNum" sz="quarter" idx="5"/>
-          </p:nvPr>
-        </p:nvSpPr>
-        <p:spPr/>
-        <p:txBody>
-          <a:bodyPr/>
-          <a:lstStyle/>
-          <a:p>
-            <a:fld id="{A20644BD-399A-490A-99CC-829CA96D1157}" type="slidenum">
-              <a:rPr lang="en-DK" smtClean="0"/>
-              <a:t>2</a:t>
-            </a:fld>
-            <a:endParaRPr lang="en-DK"/>
-          </a:p>
-        </p:txBody>
-      </p:sp>
-    </p:spTree>
-    <p:extLst>
-      <p:ext uri="{BB962C8B-B14F-4D97-AF65-F5344CB8AC3E}">
-        <p14:creationId xmlns:p14="http://schemas.microsoft.com/office/powerpoint/2010/main" val="99399054"/>
-      </p:ext>
-    </p:extLst>
-  </p:cSld>
-  <p:clrMapOvr>
-    <a:masterClrMapping/>
-  </p:clrMapOvr>
-</p:notes>
-</file>
-
 <file path=ppt/slideLayouts/slideLayout1.xml><?xml version="1.0" encoding="utf-8"?>
 <p:sldLayout xmlns:a="http://schemas.openxmlformats.org/drawingml/2006/main" xmlns:r="http://schemas.openxmlformats.org/officeDocument/2006/relationships" xmlns:p="http://schemas.openxmlformats.org/presentationml/2006/main" type="title" preserve="1">
   <p:cSld name="Title Slide">
@@ -978,7 +889,7 @@
           <a:p>
             <a:fld id="{F1465E3F-0B9F-47C9-9E08-5C827E095B3E}" type="datetimeFigureOut">
               <a:rPr lang="en-DK" smtClean="0"/>
-              <a:t>23/02/2026</a:t>
+              <a:t>24/02/2026</a:t>
             </a:fld>
             <a:endParaRPr lang="en-DK"/>
           </a:p>
@@ -1148,7 +1059,7 @@
           <a:p>
             <a:fld id="{F1465E3F-0B9F-47C9-9E08-5C827E095B3E}" type="datetimeFigureOut">
               <a:rPr lang="en-DK" smtClean="0"/>
-              <a:t>23/02/2026</a:t>
+              <a:t>24/02/2026</a:t>
             </a:fld>
             <a:endParaRPr lang="en-DK"/>
           </a:p>
@@ -1328,7 +1239,7 @@
           <a:p>
             <a:fld id="{F1465E3F-0B9F-47C9-9E08-5C827E095B3E}" type="datetimeFigureOut">
               <a:rPr lang="en-DK" smtClean="0"/>
-              <a:t>23/02/2026</a:t>
+              <a:t>24/02/2026</a:t>
             </a:fld>
             <a:endParaRPr lang="en-DK"/>
           </a:p>
@@ -1498,7 +1409,7 @@
           <a:p>
             <a:fld id="{F1465E3F-0B9F-47C9-9E08-5C827E095B3E}" type="datetimeFigureOut">
               <a:rPr lang="en-DK" smtClean="0"/>
-              <a:t>23/02/2026</a:t>
+              <a:t>24/02/2026</a:t>
             </a:fld>
             <a:endParaRPr lang="en-DK"/>
           </a:p>
@@ -1744,7 +1655,7 @@
           <a:p>
             <a:fld id="{F1465E3F-0B9F-47C9-9E08-5C827E095B3E}" type="datetimeFigureOut">
               <a:rPr lang="en-DK" smtClean="0"/>
-              <a:t>23/02/2026</a:t>
+              <a:t>24/02/2026</a:t>
             </a:fld>
             <a:endParaRPr lang="en-DK"/>
           </a:p>
@@ -1976,7 +1887,7 @@
           <a:p>
             <a:fld id="{F1465E3F-0B9F-47C9-9E08-5C827E095B3E}" type="datetimeFigureOut">
               <a:rPr lang="en-DK" smtClean="0"/>
-              <a:t>23/02/2026</a:t>
+              <a:t>24/02/2026</a:t>
             </a:fld>
             <a:endParaRPr lang="en-DK"/>
           </a:p>
@@ -2343,7 +2254,7 @@
           <a:p>
             <a:fld id="{F1465E3F-0B9F-47C9-9E08-5C827E095B3E}" type="datetimeFigureOut">
               <a:rPr lang="en-DK" smtClean="0"/>
-              <a:t>23/02/2026</a:t>
+              <a:t>24/02/2026</a:t>
             </a:fld>
             <a:endParaRPr lang="en-DK"/>
           </a:p>
@@ -2461,7 +2372,7 @@
           <a:p>
             <a:fld id="{F1465E3F-0B9F-47C9-9E08-5C827E095B3E}" type="datetimeFigureOut">
               <a:rPr lang="en-DK" smtClean="0"/>
-              <a:t>23/02/2026</a:t>
+              <a:t>24/02/2026</a:t>
             </a:fld>
             <a:endParaRPr lang="en-DK"/>
           </a:p>
@@ -2556,7 +2467,7 @@
           <a:p>
             <a:fld id="{F1465E3F-0B9F-47C9-9E08-5C827E095B3E}" type="datetimeFigureOut">
               <a:rPr lang="en-DK" smtClean="0"/>
-              <a:t>23/02/2026</a:t>
+              <a:t>24/02/2026</a:t>
             </a:fld>
             <a:endParaRPr lang="en-DK"/>
           </a:p>
@@ -2833,7 +2744,7 @@
           <a:p>
             <a:fld id="{F1465E3F-0B9F-47C9-9E08-5C827E095B3E}" type="datetimeFigureOut">
               <a:rPr lang="en-DK" smtClean="0"/>
-              <a:t>23/02/2026</a:t>
+              <a:t>24/02/2026</a:t>
             </a:fld>
             <a:endParaRPr lang="en-DK"/>
           </a:p>
@@ -3090,7 +3001,7 @@
           <a:p>
             <a:fld id="{F1465E3F-0B9F-47C9-9E08-5C827E095B3E}" type="datetimeFigureOut">
               <a:rPr lang="en-DK" smtClean="0"/>
-              <a:t>23/02/2026</a:t>
+              <a:t>24/02/2026</a:t>
             </a:fld>
             <a:endParaRPr lang="en-DK"/>
           </a:p>
@@ -3303,7 +3214,7 @@
           <a:p>
             <a:fld id="{F1465E3F-0B9F-47C9-9E08-5C827E095B3E}" type="datetimeFigureOut">
               <a:rPr lang="en-DK" smtClean="0"/>
-              <a:t>23/02/2026</a:t>
+              <a:t>24/02/2026</a:t>
             </a:fld>
             <a:endParaRPr lang="en-DK"/>
           </a:p>
@@ -3708,40 +3619,40 @@
           <a:chExt cx="0" cy="0"/>
         </a:xfrm>
       </p:grpSpPr>
+      <p:pic>
+        <p:nvPicPr>
+          <p:cNvPr id="5" name="Picture 4" descr="The image shows a user interface of the LabBench Designer software, featuring various system components such as logging, access control, and calibration, with a log directory path displayed.&#10;&#10;AI-generated content may be incorrect.">
+            <a:extLst>
+              <a:ext uri="{FF2B5EF4-FFF2-40B4-BE49-F238E27FC236}">
+                <a16:creationId xmlns:a16="http://schemas.microsoft.com/office/drawing/2014/main" id="{6EED5F7F-4672-25C9-36AF-48E7EAC96766}"/>
+              </a:ext>
+            </a:extLst>
+          </p:cNvPr>
+          <p:cNvPicPr>
+            <a:picLocks noChangeAspect="1"/>
+          </p:cNvPicPr>
+          <p:nvPr/>
+        </p:nvPicPr>
+        <p:blipFill>
+          <a:blip r:embed="rId3"/>
+          <a:stretch>
+            <a:fillRect/>
+          </a:stretch>
+        </p:blipFill>
+        <p:spPr>
+          <a:xfrm>
+            <a:off x="5804694" y="4385469"/>
+            <a:ext cx="7200000" cy="4056435"/>
+          </a:xfrm>
+          <a:prstGeom prst="rect">
+            <a:avLst/>
+          </a:prstGeom>
+        </p:spPr>
+      </p:pic>
     </p:spTree>
     <p:extLst>
       <p:ext uri="{BB962C8B-B14F-4D97-AF65-F5344CB8AC3E}">
         <p14:creationId xmlns:p14="http://schemas.microsoft.com/office/powerpoint/2010/main" val="786876301"/>
-      </p:ext>
-    </p:extLst>
-  </p:cSld>
-  <p:clrMapOvr>
-    <a:masterClrMapping/>
-  </p:clrMapOvr>
-</p:sld>
-</file>
-
-<file path=ppt/slides/slide2.xml><?xml version="1.0" encoding="utf-8"?>
-<p:sld xmlns:a="http://schemas.openxmlformats.org/drawingml/2006/main" xmlns:r="http://schemas.openxmlformats.org/officeDocument/2006/relationships" xmlns:p="http://schemas.openxmlformats.org/presentationml/2006/main">
-  <p:cSld>
-    <p:spTree>
-      <p:nvGrpSpPr>
-        <p:cNvPr id="1" name=""/>
-        <p:cNvGrpSpPr/>
-        <p:nvPr/>
-      </p:nvGrpSpPr>
-      <p:grpSpPr>
-        <a:xfrm>
-          <a:off x="0" y="0"/>
-          <a:ext cx="0" cy="0"/>
-          <a:chOff x="0" y="0"/>
-          <a:chExt cx="0" cy="0"/>
-        </a:xfrm>
-      </p:grpSpPr>
-    </p:spTree>
-    <p:extLst>
-      <p:ext uri="{BB962C8B-B14F-4D97-AF65-F5344CB8AC3E}">
-        <p14:creationId xmlns:p14="http://schemas.microsoft.com/office/powerpoint/2010/main" val="2435479675"/>
       </p:ext>
     </p:extLst>
   </p:cSld>
@@ -4637,6 +4548,15 @@
 </file>
 
 <file path=customXml/item2.xml><?xml version="1.0" encoding="utf-8"?>
+<?mso-contentType ?>
+<FormTemplates xmlns="http://schemas.microsoft.com/sharepoint/v3/contenttype/forms">
+  <Display>DocumentLibraryForm</Display>
+  <Edit>DocumentLibraryForm</Edit>
+  <New>DocumentLibraryForm</New>
+</FormTemplates>
+</file>
+
+<file path=customXml/item3.xml><?xml version="1.0" encoding="utf-8"?>
 <p:properties xmlns:p="http://schemas.microsoft.com/office/2006/metadata/properties" xmlns:xsi="http://www.w3.org/2001/XMLSchema-instance" xmlns:pc="http://schemas.microsoft.com/office/infopath/2007/PartnerControls">
   <documentManagement>
     <TaxCatchAll xmlns="6dfb7b4b-871d-4c24-9d42-16b14ecd044c" xsi:nil="true"/>
@@ -4645,15 +4565,6 @@
     </lcf76f155ced4ddcb4097134ff3c332f>
   </documentManagement>
 </p:properties>
-</file>
-
-<file path=customXml/item3.xml><?xml version="1.0" encoding="utf-8"?>
-<?mso-contentType ?>
-<FormTemplates xmlns="http://schemas.microsoft.com/sharepoint/v3/contenttype/forms">
-  <Display>DocumentLibraryForm</Display>
-  <Edit>DocumentLibraryForm</Edit>
-  <New>DocumentLibraryForm</New>
-</FormTemplates>
 </file>
 
 <file path=customXml/itemProps1.xml><?xml version="1.0" encoding="utf-8"?>
@@ -4676,20 +4587,26 @@
 </file>
 
 <file path=customXml/itemProps2.xml><?xml version="1.0" encoding="utf-8"?>
-<ds:datastoreItem xmlns:ds="http://schemas.openxmlformats.org/officeDocument/2006/customXml" ds:itemID="{2EF670CE-B0AA-4D52-AFC6-AA4BF7D46EEA}">
+<ds:datastoreItem xmlns:ds="http://schemas.openxmlformats.org/officeDocument/2006/customXml" ds:itemID="{EF875D47-8106-485E-98E0-D60C6A98DA6A}">
   <ds:schemaRefs>
-    <ds:schemaRef ds:uri="http://schemas.microsoft.com/office/2006/metadata/properties"/>
-    <ds:schemaRef ds:uri="http://schemas.microsoft.com/office/infopath/2007/PartnerControls"/>
-    <ds:schemaRef ds:uri="6dfb7b4b-871d-4c24-9d42-16b14ecd044c"/>
-    <ds:schemaRef ds:uri="51c7d8ad-74c8-4833-8478-0d0a5cafce0c"/>
+    <ds:schemaRef ds:uri="http://schemas.microsoft.com/sharepoint/v3/contenttype/forms"/>
   </ds:schemaRefs>
 </ds:datastoreItem>
 </file>
 
 <file path=customXml/itemProps3.xml><?xml version="1.0" encoding="utf-8"?>
-<ds:datastoreItem xmlns:ds="http://schemas.openxmlformats.org/officeDocument/2006/customXml" ds:itemID="{EF875D47-8106-485E-98E0-D60C6A98DA6A}">
+<ds:datastoreItem xmlns:ds="http://schemas.openxmlformats.org/officeDocument/2006/customXml" ds:itemID="{2EF670CE-B0AA-4D52-AFC6-AA4BF7D46EEA}">
   <ds:schemaRefs>
-    <ds:schemaRef ds:uri="http://schemas.microsoft.com/sharepoint/v3/contenttype/forms"/>
+    <ds:schemaRef ds:uri="http://schemas.microsoft.com/office/2006/metadata/properties"/>
+    <ds:schemaRef ds:uri="http://purl.org/dc/elements/1.1/"/>
+    <ds:schemaRef ds:uri="http://schemas.openxmlformats.org/package/2006/metadata/core-properties"/>
+    <ds:schemaRef ds:uri="http://schemas.microsoft.com/office/2006/documentManagement/types"/>
+    <ds:schemaRef ds:uri="6dfb7b4b-871d-4c24-9d42-16b14ecd044c"/>
+    <ds:schemaRef ds:uri="http://purl.org/dc/dcmitype/"/>
+    <ds:schemaRef ds:uri="http://purl.org/dc/terms/"/>
+    <ds:schemaRef ds:uri="http://www.w3.org/XML/1998/namespace"/>
+    <ds:schemaRef ds:uri="http://schemas.microsoft.com/office/infopath/2007/PartnerControls"/>
+    <ds:schemaRef ds:uri="51c7d8ad-74c8-4833-8478-0d0a5cafce0c"/>
   </ds:schemaRefs>
 </ds:datastoreItem>
 </file>
</xml_diff>